<commit_message>
Update course materials and presentations for the new course date
- Changed course date from 19.10.2026 to 25.10.2026 in various documents.
- Revised course objectives and structure in organisation.md.
- Enhanced content in tag-1.md, tag-2.md, tag-5.md to reflect updated course flow and activities.
- Added new presentation for course introduction and updated existing presentations for consistency.
- Adjusted exit ticket process and feedback mechanisms in course leadership documentation.
- Improved clarity in instructions and tasks across all course materials.
</commit_message>
<xml_diff>
--- a/praesentationen/tag-2-azure-grundlagen.pptx
+++ b/praesentationen/tag-2-azure-grundlagen.pptx
@@ -114,13 +114,13 @@
   <p:extLst>
     <p:ext uri="{521415D9-36F7-43E2-AB2F-B90AF26B5E84}">
       <p14:sectionLst xmlns:p14="http://schemas.microsoft.com/office/powerpoint/2010/main">
-        <p14:section name="Start" id="{46f74d5b-fba3-f551-2562-d11e664e2abf}">
+        <p14:section name="Start" id="{aa4c6517-7f03-53da-e74f-a925fb0209cc}">
           <p14:sldIdLst>
             <p14:sldId id="256"/>
             <p14:sldId id="257"/>
           </p14:sldIdLst>
         </p14:section>
-        <p14:section name="Heute" id="{50396167-b3dd-35a2-31a2-8d725bc3d195}">
+        <p14:section name="Heute" id="{b5d60fb0-e291-e7be-31a6-ea9223b20aa2}">
           <p14:sldIdLst>
             <p14:sldId id="258"/>
             <p14:sldId id="259"/>
@@ -128,7 +128,7 @@
             <p14:sldId id="261"/>
           </p14:sldIdLst>
         </p14:section>
-        <p14:section name="Abschluss" id="{32ad7a95-e400-97c8-8e9c-8d13d182b9ec}">
+        <p14:section name="Abschluss" id="{50df2e42-bf47-6a06-6d15-8c48ebcc19b7}">
           <p14:sldIdLst>
             <p14:sldId id="262"/>
             <p14:sldId id="263"/>
@@ -1232,7 +1232,7 @@
     <p:bg>
       <p:bgPr>
         <a:solidFill>
-          <a:srgbClr val="27303A"/>
+          <a:srgbClr val="FFFFFF"/>
         </a:solidFill>
       </p:bgPr>
     </p:bg>
@@ -1252,7 +1252,7 @@
       </p:grpSpPr>
       <p:pic>
         <p:nvPicPr>
-          <p:cNvPr id="2" name="Image 0" descr="C:\Users\Thanam\AppData\Local\Temp\claude\c--Projekt-Trainings-azure-basics-training\a9e0bf4e-0d08-4082-a38a-5b8886538508\scratchpad\pptx\assets\logo-hell.png">    </p:cNvPr>
+          <p:cNvPr id="2" name="Image 0" descr="C:\Users\Thanam\AppData\Local\Temp\claude\c--Projekt-Trainings-azure-basics-training\a7a6b8eb-22f3-4b42-aecc-5af05d1502b1\scratchpad\folien\assets\logo-dunkel.png">    </p:cNvPr>
           <p:cNvPicPr>
             <a:picLocks noChangeAspect="1"/>
           </p:cNvPicPr>
@@ -1276,7 +1276,7 @@
       </p:pic>
       <p:pic>
         <p:nvPicPr>
-          <p:cNvPr id="3" name="Image 1" descr="C:\Users\Thanam\AppData\Local\Temp\claude\c--Projekt-Trainings-azure-basics-training\a9e0bf4e-0d08-4082-a38a-5b8886538508\scratchpad\pptx\assets\wolke.png">    </p:cNvPr>
+          <p:cNvPr id="3" name="Image 1" descr="C:\Users\Thanam\AppData\Local\Temp\claude\c--Projekt-Trainings-azure-basics-training\a7a6b8eb-22f3-4b42-aecc-5af05d1502b1\scratchpad\folien\assets\wolke.png">    </p:cNvPr>
           <p:cNvPicPr>
             <a:picLocks noChangeAspect="1"/>
           </p:cNvPicPr>
@@ -1324,7 +1324,7 @@
               <a:buNone/>
               <a:defRPr lang="en-US" sz="4400" b="1" dirty="0">
                 <a:solidFill>
-                  <a:srgbClr val="FFFFFF"/>
+                  <a:srgbClr val="27303A"/>
                 </a:solidFill>
               </a:defRPr>
             </a:lvl1pPr>
@@ -1363,7 +1363,7 @@
               <a:buNone/>
               <a:defRPr lang="en-US" sz="2000" dirty="0">
                 <a:solidFill>
-                  <a:srgbClr val="DEE2FB"/>
+                  <a:srgbClr val="006FAD"/>
                 </a:solidFill>
               </a:defRPr>
             </a:lvl1pPr>
@@ -1403,7 +1403,7 @@
             <a:r>
               <a:rPr lang="en-US" sz="1200" dirty="0">
                 <a:solidFill>
-                  <a:srgbClr val="DEE2FB"/>
+                  <a:srgbClr val="6F6F6F"/>
                 </a:solidFill>
               </a:rPr>
               <a:t>Kanton Zürich · ICT-Grundbildung · PAT Cloud Solutions</a:t>
@@ -1426,7 +1426,7 @@
     <p:bg>
       <p:bgPr>
         <a:solidFill>
-          <a:srgbClr val="006FAD"/>
+          <a:srgbClr val="F7F7F7"/>
         </a:solidFill>
       </p:bgPr>
     </p:bg>
@@ -1446,7 +1446,7 @@
       </p:grpSpPr>
       <p:pic>
         <p:nvPicPr>
-          <p:cNvPr id="2" name="Image 0" descr="C:\Users\Thanam\AppData\Local\Temp\claude\c--Projekt-Trainings-azure-basics-training\a9e0bf4e-0d08-4082-a38a-5b8886538508\scratchpad\pptx\assets\wolke.png">    </p:cNvPr>
+          <p:cNvPr id="2" name="Image 0" descr="C:\Users\Thanam\AppData\Local\Temp\claude\c--Projekt-Trainings-azure-basics-training\a7a6b8eb-22f3-4b42-aecc-5af05d1502b1\scratchpad\folien\assets\wolke.png">    </p:cNvPr>
           <p:cNvPicPr>
             <a:picLocks noChangeAspect="1"/>
           </p:cNvPicPr>
@@ -1470,7 +1470,7 @@
       </p:pic>
       <p:pic>
         <p:nvPicPr>
-          <p:cNvPr id="3" name="Image 1" descr="C:\Users\Thanam\AppData\Local\Temp\claude\c--Projekt-Trainings-azure-basics-training\a9e0bf4e-0d08-4082-a38a-5b8886538508\scratchpad\pptx\assets\logo-hell.png">    </p:cNvPr>
+          <p:cNvPr id="3" name="Image 1" descr="C:\Users\Thanam\AppData\Local\Temp\claude\c--Projekt-Trainings-azure-basics-training\a7a6b8eb-22f3-4b42-aecc-5af05d1502b1\scratchpad\folien\assets\logo-dunkel.png">    </p:cNvPr>
           <p:cNvPicPr>
             <a:picLocks noChangeAspect="1"/>
           </p:cNvPicPr>
@@ -1518,7 +1518,7 @@
               <a:buNone/>
               <a:defRPr lang="en-US" sz="4000" b="1" dirty="0">
                 <a:solidFill>
-                  <a:srgbClr val="FFFFFF"/>
+                  <a:srgbClr val="27303A"/>
                 </a:solidFill>
               </a:defRPr>
             </a:lvl1pPr>
@@ -1557,7 +1557,7 @@
               <a:buNone/>
               <a:defRPr lang="en-US" sz="2000" dirty="0">
                 <a:solidFill>
-                  <a:srgbClr val="DEE2FB"/>
+                  <a:srgbClr val="006FAD"/>
                 </a:solidFill>
               </a:defRPr>
             </a:lvl1pPr>
@@ -1604,7 +1604,7 @@
       </p:grpSpPr>
       <p:pic>
         <p:nvPicPr>
-          <p:cNvPr id="2" name="Image 0" descr="C:\Users\Thanam\AppData\Local\Temp\claude\c--Projekt-Trainings-azure-basics-training\a9e0bf4e-0d08-4082-a38a-5b8886538508\scratchpad\pptx\assets\logo-dunkel.png">    </p:cNvPr>
+          <p:cNvPr id="2" name="Image 0" descr="C:\Users\Thanam\AppData\Local\Temp\claude\c--Projekt-Trainings-azure-basics-training\a7a6b8eb-22f3-4b42-aecc-5af05d1502b1\scratchpad\folien\assets\logo-dunkel.png">    </p:cNvPr>
           <p:cNvPicPr>
             <a:picLocks noChangeAspect="1"/>
           </p:cNvPicPr>
@@ -1760,7 +1760,7 @@
     <p:bg>
       <p:bgPr>
         <a:solidFill>
-          <a:srgbClr val="27303A"/>
+          <a:srgbClr val="FFFFFF"/>
         </a:solidFill>
       </p:bgPr>
     </p:bg>
@@ -1780,7 +1780,7 @@
       </p:grpSpPr>
       <p:pic>
         <p:nvPicPr>
-          <p:cNvPr id="2" name="Image 0" descr="C:\Users\Thanam\AppData\Local\Temp\claude\c--Projekt-Trainings-azure-basics-training\a9e0bf4e-0d08-4082-a38a-5b8886538508\scratchpad\pptx\assets\logo-hell.png">    </p:cNvPr>
+          <p:cNvPr id="2" name="Image 0" descr="C:\Users\Thanam\AppData\Local\Temp\claude\c--Projekt-Trainings-azure-basics-training\a7a6b8eb-22f3-4b42-aecc-5af05d1502b1\scratchpad\folien\assets\logo-dunkel.png">    </p:cNvPr>
           <p:cNvPicPr>
             <a:picLocks noChangeAspect="1"/>
           </p:cNvPicPr>
@@ -1828,7 +1828,7 @@
               <a:buNone/>
               <a:defRPr lang="en-US" sz="4000" b="1" dirty="0">
                 <a:solidFill>
-                  <a:srgbClr val="FFFFFF"/>
+                  <a:srgbClr val="27303A"/>
                 </a:solidFill>
               </a:defRPr>
             </a:lvl1pPr>
@@ -1867,7 +1867,7 @@
               <a:buNone/>
               <a:defRPr lang="en-US" sz="2000" dirty="0">
                 <a:solidFill>
-                  <a:srgbClr val="DEE2FB"/>
+                  <a:srgbClr val="006FAD"/>
                 </a:solidFill>
               </a:defRPr>
             </a:lvl1pPr>
@@ -2260,7 +2260,7 @@
             <a:r>
               <a:rPr lang="en-US" sz="4400" b="1" dirty="0">
                 <a:solidFill>
-                  <a:srgbClr val="FFFFFF"/>
+                  <a:srgbClr val="27303A"/>
                 </a:solidFill>
               </a:rPr>
               <a:t>Tag 2: Public Cloud und Azure Grundlagen</a:t>
@@ -2298,7 +2298,7 @@
             <a:r>
               <a:rPr lang="en-US" sz="2000" dirty="0">
                 <a:solidFill>
-                  <a:srgbClr val="DEE2FB"/>
+                  <a:srgbClr val="006FAD"/>
                 </a:solidFill>
               </a:rPr>
               <a:t>Einführung in Cloud Computing mit Microsoft Azure</a:t>
@@ -2460,7 +2460,7 @@
       </p:sp>
       <p:pic>
         <p:nvPicPr>
-          <p:cNvPr id="6" name="icon-FaQuestionCircle" descr="C:\Users\Thanam\AppData\Local\Temp\claude\c--Projekt-Trainings-azure-basics-training\a9e0bf4e-0d08-4082-a38a-5b8886538508\scratchpad\pptx\assets\icons\FaQuestionCircle.png">    </p:cNvPr>
+          <p:cNvPr id="6" name="icon-FaQuestionCircle" descr="C:\Users\Thanam\AppData\Local\Temp\claude\c--Projekt-Trainings-azure-basics-training\a7a6b8eb-22f3-4b42-aecc-5af05d1502b1\scratchpad\folien\assets\icons\FaQuestionCircle.png">    </p:cNvPr>
           <p:cNvPicPr>
             <a:picLocks noChangeAspect="1"/>
           </p:cNvPicPr>
@@ -2613,7 +2613,7 @@
       </p:sp>
       <p:pic>
         <p:nvPicPr>
-          <p:cNvPr id="11" name="icon-FaQuestionCircle" descr="C:\Users\Thanam\AppData\Local\Temp\claude\c--Projekt-Trainings-azure-basics-training\a9e0bf4e-0d08-4082-a38a-5b8886538508\scratchpad\pptx\assets\icons\FaQuestionCircle.png">    </p:cNvPr>
+          <p:cNvPr id="11" name="icon-FaQuestionCircle" descr="C:\Users\Thanam\AppData\Local\Temp\claude\c--Projekt-Trainings-azure-basics-training\a7a6b8eb-22f3-4b42-aecc-5af05d1502b1\scratchpad\folien\assets\icons\FaQuestionCircle.png">    </p:cNvPr>
           <p:cNvPicPr>
             <a:picLocks noChangeAspect="1"/>
           </p:cNvPicPr>
@@ -2766,7 +2766,7 @@
       </p:sp>
       <p:pic>
         <p:nvPicPr>
-          <p:cNvPr id="16" name="icon-FaQuestionCircle" descr="C:\Users\Thanam\AppData\Local\Temp\claude\c--Projekt-Trainings-azure-basics-training\a9e0bf4e-0d08-4082-a38a-5b8886538508\scratchpad\pptx\assets\icons\FaQuestionCircle.png">    </p:cNvPr>
+          <p:cNvPr id="16" name="icon-FaQuestionCircle" descr="C:\Users\Thanam\AppData\Local\Temp\claude\c--Projekt-Trainings-azure-basics-training\a7a6b8eb-22f3-4b42-aecc-5af05d1502b1\scratchpad\folien\assets\icons\FaQuestionCircle.png">    </p:cNvPr>
           <p:cNvPicPr>
             <a:picLocks noChangeAspect="1"/>
           </p:cNvPicPr>
@@ -3027,7 +3027,7 @@
       </p:sp>
       <p:pic>
         <p:nvPicPr>
-          <p:cNvPr id="5" name="icon-FaCloud" descr="C:\Users\Thanam\AppData\Local\Temp\claude\c--Projekt-Trainings-azure-basics-training\a9e0bf4e-0d08-4082-a38a-5b8886538508\scratchpad\pptx\assets\icons\FaCloud.png">    </p:cNvPr>
+          <p:cNvPr id="5" name="icon-FaCloud" descr="C:\Users\Thanam\AppData\Local\Temp\claude\c--Projekt-Trainings-azure-basics-training\a7a6b8eb-22f3-4b42-aecc-5af05d1502b1\scratchpad\folien\assets\icons\FaCloud.png">    </p:cNvPr>
           <p:cNvPicPr>
             <a:picLocks noChangeAspect="1"/>
           </p:cNvPicPr>
@@ -3180,7 +3180,7 @@
       </p:sp>
       <p:pic>
         <p:nvPicPr>
-          <p:cNvPr id="10" name="icon-FaGlobeEurope" descr="C:\Users\Thanam\AppData\Local\Temp\claude\c--Projekt-Trainings-azure-basics-training\a9e0bf4e-0d08-4082-a38a-5b8886538508\scratchpad\pptx\assets\icons\FaGlobeEurope.png">    </p:cNvPr>
+          <p:cNvPr id="10" name="icon-FaGlobeEurope" descr="C:\Users\Thanam\AppData\Local\Temp\claude\c--Projekt-Trainings-azure-basics-training\a7a6b8eb-22f3-4b42-aecc-5af05d1502b1\scratchpad\folien\assets\icons\FaGlobeEurope.png">    </p:cNvPr>
           <p:cNvPicPr>
             <a:picLocks noChangeAspect="1"/>
           </p:cNvPicPr>
@@ -3333,7 +3333,7 @@
       </p:sp>
       <p:pic>
         <p:nvPicPr>
-          <p:cNvPr id="15" name="icon-FaTerminal" descr="C:\Users\Thanam\AppData\Local\Temp\claude\c--Projekt-Trainings-azure-basics-training\a9e0bf4e-0d08-4082-a38a-5b8886538508\scratchpad\pptx\assets\icons\FaTerminal.png">    </p:cNvPr>
+          <p:cNvPr id="15" name="icon-FaTerminal" descr="C:\Users\Thanam\AppData\Local\Temp\claude\c--Projekt-Trainings-azure-basics-training\a7a6b8eb-22f3-4b42-aecc-5af05d1502b1\scratchpad\folien\assets\icons\FaTerminal.png">    </p:cNvPr>
           <p:cNvPicPr>
             <a:picLocks noChangeAspect="1"/>
           </p:cNvPicPr>
@@ -7691,7 +7691,7 @@
       </p:sp>
       <p:pic>
         <p:nvPicPr>
-          <p:cNvPr id="5" name="icon-FaTrashAlt" descr="C:\Users\Thanam\AppData\Local\Temp\claude\c--Projekt-Trainings-azure-basics-training\a9e0bf4e-0d08-4082-a38a-5b8886538508\scratchpad\pptx\assets\icons\FaTrashAlt.png">    </p:cNvPr>
+          <p:cNvPr id="5" name="icon-FaTrashAlt" descr="C:\Users\Thanam\AppData\Local\Temp\claude\c--Projekt-Trainings-azure-basics-training\a7a6b8eb-22f3-4b42-aecc-5af05d1502b1\scratchpad\folien\assets\icons\FaTrashAlt.png">    </p:cNvPr>
           <p:cNvPicPr>
             <a:picLocks noChangeAspect="1"/>
           </p:cNvPicPr>
@@ -7844,7 +7844,7 @@
       </p:sp>
       <p:pic>
         <p:nvPicPr>
-          <p:cNvPr id="10" name="icon-FaDoorOpen" descr="C:\Users\Thanam\AppData\Local\Temp\claude\c--Projekt-Trainings-azure-basics-training\a9e0bf4e-0d08-4082-a38a-5b8886538508\scratchpad\pptx\assets\icons\FaDoorOpen.png">    </p:cNvPr>
+          <p:cNvPr id="10" name="icon-FaDoorOpen" descr="C:\Users\Thanam\AppData\Local\Temp\claude\c--Projekt-Trainings-azure-basics-training\a7a6b8eb-22f3-4b42-aecc-5af05d1502b1\scratchpad\folien\assets\icons\FaDoorOpen.png">    </p:cNvPr>
           <p:cNvPicPr>
             <a:picLocks noChangeAspect="1"/>
           </p:cNvPicPr>
@@ -8042,10 +8042,10 @@
             <a:r>
               <a:rPr lang="en-US" sz="4000" b="1" dirty="0">
                 <a:solidFill>
-                  <a:srgbClr val="FFFFFF"/>
+                  <a:srgbClr val="27303A"/>
                 </a:solidFill>
               </a:rPr>
-              <a:t>Morgen: deine erste VM in Azure</a:t>
+              <a:t>Nächstes Mal: deine erste VM in Azure</a:t>
             </a:r>
             <a:endParaRPr lang="en-US" sz="4000" dirty="0"/>
           </a:p>
@@ -8080,7 +8080,7 @@
             <a:r>
               <a:rPr lang="en-US" sz="2000" dirty="0">
                 <a:solidFill>
-                  <a:srgbClr val="DEE2FB"/>
+                  <a:srgbClr val="006FAD"/>
                 </a:solidFill>
               </a:rPr>
               <a:t>Tag 3 · Azure Compute und Storage</a:t>
@@ -8091,7 +8091,7 @@
       </p:sp>
       <p:sp>
         <p:nvSpPr>
-          <p:cNvPr id="4" name="karte-dunkel"/>
+          <p:cNvPr id="4" name="karte"/>
           <p:cNvSpPr/>
           <p:nvPr/>
         </p:nvSpPr>
@@ -8106,11 +8106,11 @@
             </a:avLst>
           </a:prstGeom>
           <a:solidFill>
-            <a:srgbClr val="323C48"/>
+            <a:srgbClr val="F7F7F7"/>
           </a:solidFill>
           <a:ln w="12700">
             <a:solidFill>
-              <a:srgbClr val="323C48"/>
+              <a:srgbClr val="F7F7F7"/>
             </a:solidFill>
             <a:prstDash val="solid"/>
           </a:ln>
@@ -8143,7 +8143,7 @@
       </p:sp>
       <p:pic>
         <p:nvPicPr>
-          <p:cNvPr id="6" name="icon-FaKey" descr="C:\Users\Thanam\AppData\Local\Temp\claude\c--Projekt-Trainings-azure-basics-training\a9e0bf4e-0d08-4082-a38a-5b8886538508\scratchpad\pptx\assets\icons\FaKey.png">    </p:cNvPr>
+          <p:cNvPr id="6" name="icon-FaKey" descr="C:\Users\Thanam\AppData\Local\Temp\claude\c--Projekt-Trainings-azure-basics-training\a7a6b8eb-22f3-4b42-aecc-5af05d1502b1\scratchpad\folien\assets\icons\FaKey.png">    </p:cNvPr>
           <p:cNvPicPr>
             <a:picLocks noChangeAspect="1"/>
           </p:cNvPicPr>
@@ -8192,7 +8192,7 @@
             <a:r>
               <a:rPr lang="en-US" sz="2000" b="1" dirty="0">
                 <a:solidFill>
-                  <a:srgbClr val="FFFFFF"/>
+                  <a:srgbClr val="27303A"/>
                 </a:solidFill>
               </a:rPr>
               <a:t>SSH-Schlüssel</a:t>
@@ -8228,7 +8228,7 @@
             <a:r>
               <a:rPr lang="en-US" sz="1600" dirty="0">
                 <a:solidFill>
-                  <a:srgbClr val="DEE2FB"/>
+                  <a:srgbClr val="27303A"/>
                 </a:solidFill>
               </a:rPr>
               <a:t>Den Schlüssel von Tag 1 brauchst du wieder.</a:t>
@@ -8239,7 +8239,7 @@
       </p:sp>
       <p:sp>
         <p:nvSpPr>
-          <p:cNvPr id="9" name="karte-dunkel"/>
+          <p:cNvPr id="9" name="karte"/>
           <p:cNvSpPr/>
           <p:nvPr/>
         </p:nvSpPr>
@@ -8254,11 +8254,11 @@
             </a:avLst>
           </a:prstGeom>
           <a:solidFill>
-            <a:srgbClr val="323C48"/>
+            <a:srgbClr val="F7F7F7"/>
           </a:solidFill>
           <a:ln w="12700">
             <a:solidFill>
-              <a:srgbClr val="323C48"/>
+              <a:srgbClr val="F7F7F7"/>
             </a:solidFill>
             <a:prstDash val="solid"/>
           </a:ln>
@@ -8291,7 +8291,7 @@
       </p:sp>
       <p:pic>
         <p:nvPicPr>
-          <p:cNvPr id="11" name="icon-FaServer" descr="C:\Users\Thanam\AppData\Local\Temp\claude\c--Projekt-Trainings-azure-basics-training\a9e0bf4e-0d08-4082-a38a-5b8886538508\scratchpad\pptx\assets\icons\FaServer.png">    </p:cNvPr>
+          <p:cNvPr id="11" name="icon-FaServer" descr="C:\Users\Thanam\AppData\Local\Temp\claude\c--Projekt-Trainings-azure-basics-training\a7a6b8eb-22f3-4b42-aecc-5af05d1502b1\scratchpad\folien\assets\icons\FaServer.png">    </p:cNvPr>
           <p:cNvPicPr>
             <a:picLocks noChangeAspect="1"/>
           </p:cNvPicPr>
@@ -8340,7 +8340,7 @@
             <a:r>
               <a:rPr lang="en-US" sz="2000" b="1" dirty="0">
                 <a:solidFill>
-                  <a:srgbClr val="FFFFFF"/>
+                  <a:srgbClr val="27303A"/>
                 </a:solidFill>
               </a:rPr>
               <a:t>VM in Azure</a:t>
@@ -8376,7 +8376,7 @@
             <a:r>
               <a:rPr lang="en-US" sz="1600" dirty="0">
                 <a:solidFill>
-                  <a:srgbClr val="DEE2FB"/>
+                  <a:srgbClr val="27303A"/>
                 </a:solidFill>
               </a:rPr>
               <a:t>Vergleich mit deiner lokalen VM</a:t>

</xml_diff>